<commit_message>
worked on workflow figure, box and many parts of manuscript
</commit_message>
<xml_diff>
--- a/analyses/figures/figures_simulation.pptx
+++ b/analyses/figures/figures_simulation.pptx
@@ -225,7 +225,7 @@
           <a:p>
             <a:fld id="{2F135446-6881-F24D-BECD-617636E10D62}" type="datetimeFigureOut">
               <a:rPr lang="en-US" smtClean="0"/>
-              <a:t>8/27/24</a:t>
+              <a:t>8/12/26</a:t>
             </a:fld>
             <a:endParaRPr lang="en-US"/>
           </a:p>
@@ -807,7 +807,7 @@
           <a:p>
             <a:fld id="{7A0C4CA1-6CF3-4D46-A80D-8B75430028DB}" type="datetimeFigureOut">
               <a:rPr lang="en-US" smtClean="0"/>
-              <a:t>8/27/24</a:t>
+              <a:t>8/12/26</a:t>
             </a:fld>
             <a:endParaRPr lang="en-US"/>
           </a:p>
@@ -1005,7 +1005,7 @@
           <a:p>
             <a:fld id="{7A0C4CA1-6CF3-4D46-A80D-8B75430028DB}" type="datetimeFigureOut">
               <a:rPr lang="en-US" smtClean="0"/>
-              <a:t>8/27/24</a:t>
+              <a:t>8/12/26</a:t>
             </a:fld>
             <a:endParaRPr lang="en-US"/>
           </a:p>
@@ -1213,7 +1213,7 @@
           <a:p>
             <a:fld id="{7A0C4CA1-6CF3-4D46-A80D-8B75430028DB}" type="datetimeFigureOut">
               <a:rPr lang="en-US" smtClean="0"/>
-              <a:t>8/27/24</a:t>
+              <a:t>8/12/26</a:t>
             </a:fld>
             <a:endParaRPr lang="en-US"/>
           </a:p>
@@ -1411,7 +1411,7 @@
           <a:p>
             <a:fld id="{7A0C4CA1-6CF3-4D46-A80D-8B75430028DB}" type="datetimeFigureOut">
               <a:rPr lang="en-US" smtClean="0"/>
-              <a:t>8/27/24</a:t>
+              <a:t>8/12/26</a:t>
             </a:fld>
             <a:endParaRPr lang="en-US"/>
           </a:p>
@@ -1686,7 +1686,7 @@
           <a:p>
             <a:fld id="{7A0C4CA1-6CF3-4D46-A80D-8B75430028DB}" type="datetimeFigureOut">
               <a:rPr lang="en-US" smtClean="0"/>
-              <a:t>8/27/24</a:t>
+              <a:t>8/12/26</a:t>
             </a:fld>
             <a:endParaRPr lang="en-US"/>
           </a:p>
@@ -1951,7 +1951,7 @@
           <a:p>
             <a:fld id="{7A0C4CA1-6CF3-4D46-A80D-8B75430028DB}" type="datetimeFigureOut">
               <a:rPr lang="en-US" smtClean="0"/>
-              <a:t>8/27/24</a:t>
+              <a:t>8/12/26</a:t>
             </a:fld>
             <a:endParaRPr lang="en-US"/>
           </a:p>
@@ -2363,7 +2363,7 @@
           <a:p>
             <a:fld id="{7A0C4CA1-6CF3-4D46-A80D-8B75430028DB}" type="datetimeFigureOut">
               <a:rPr lang="en-US" smtClean="0"/>
-              <a:t>8/27/24</a:t>
+              <a:t>8/12/26</a:t>
             </a:fld>
             <a:endParaRPr lang="en-US"/>
           </a:p>
@@ -2504,7 +2504,7 @@
           <a:p>
             <a:fld id="{7A0C4CA1-6CF3-4D46-A80D-8B75430028DB}" type="datetimeFigureOut">
               <a:rPr lang="en-US" smtClean="0"/>
-              <a:t>8/27/24</a:t>
+              <a:t>8/12/26</a:t>
             </a:fld>
             <a:endParaRPr lang="en-US"/>
           </a:p>
@@ -2617,7 +2617,7 @@
           <a:p>
             <a:fld id="{7A0C4CA1-6CF3-4D46-A80D-8B75430028DB}" type="datetimeFigureOut">
               <a:rPr lang="en-US" smtClean="0"/>
-              <a:t>8/27/24</a:t>
+              <a:t>8/12/26</a:t>
             </a:fld>
             <a:endParaRPr lang="en-US"/>
           </a:p>
@@ -2928,7 +2928,7 @@
           <a:p>
             <a:fld id="{7A0C4CA1-6CF3-4D46-A80D-8B75430028DB}" type="datetimeFigureOut">
               <a:rPr lang="en-US" smtClean="0"/>
-              <a:t>8/27/24</a:t>
+              <a:t>8/12/26</a:t>
             </a:fld>
             <a:endParaRPr lang="en-US"/>
           </a:p>
@@ -3216,7 +3216,7 @@
           <a:p>
             <a:fld id="{7A0C4CA1-6CF3-4D46-A80D-8B75430028DB}" type="datetimeFigureOut">
               <a:rPr lang="en-US" smtClean="0"/>
-              <a:t>8/27/24</a:t>
+              <a:t>8/12/26</a:t>
             </a:fld>
             <a:endParaRPr lang="en-US"/>
           </a:p>
@@ -3457,7 +3457,7 @@
           <a:p>
             <a:fld id="{7A0C4CA1-6CF3-4D46-A80D-8B75430028DB}" type="datetimeFigureOut">
               <a:rPr lang="en-US" smtClean="0"/>
-              <a:t>8/27/24</a:t>
+              <a:t>8/12/26</a:t>
             </a:fld>
             <a:endParaRPr lang="en-US"/>
           </a:p>
@@ -8573,10 +8573,10 @@
         </p:nvGrpSpPr>
         <p:grpSpPr>
           <a:xfrm>
-            <a:off x="-574228" y="-96887"/>
-            <a:ext cx="12626743" cy="7051773"/>
-            <a:chOff x="-347256" y="-30409"/>
-            <a:chExt cx="12626743" cy="7051773"/>
+            <a:off x="-574228" y="445734"/>
+            <a:ext cx="12439232" cy="6509152"/>
+            <a:chOff x="-347256" y="512212"/>
+            <a:chExt cx="12439232" cy="6509152"/>
           </a:xfrm>
         </p:grpSpPr>
         <p:sp>
@@ -9089,7 +9089,7 @@
           </p:nvSpPr>
           <p:spPr>
             <a:xfrm>
-              <a:off x="7425552" y="4998423"/>
+              <a:off x="7579309" y="5078423"/>
               <a:ext cx="2259126" cy="523220"/>
             </a:xfrm>
             <a:prstGeom prst="rect">
@@ -9560,7 +9560,7 @@
           </p:nvSpPr>
           <p:spPr>
             <a:xfrm>
-              <a:off x="7792774" y="5611504"/>
+              <a:off x="8617327" y="4287032"/>
               <a:ext cx="2887358" cy="307777"/>
             </a:xfrm>
             <a:prstGeom prst="rect">
@@ -9599,8 +9599,8 @@
           </p:nvSpPr>
           <p:spPr>
             <a:xfrm>
-              <a:off x="8885326" y="3854333"/>
-              <a:ext cx="3363165" cy="954107"/>
+              <a:off x="8728811" y="3983093"/>
+              <a:ext cx="3363165" cy="307777"/>
             </a:xfrm>
             <a:prstGeom prst="rect">
               <a:avLst/>
@@ -9619,7 +9619,7 @@
                     <a:srgbClr val="FF0000"/>
                   </a:solidFill>
                 </a:rPr>
-                <a:t>Not meaningful/testable (vague, subjective, unrealistic, multidirectional or without direction), i.e. the null hypothesis gets rejected in all cases</a:t>
+                <a:t>Vague or untestable hypothesis</a:t>
               </a:r>
             </a:p>
           </p:txBody>
@@ -9658,7 +9658,7 @@
                     <a:srgbClr val="FF0000"/>
                   </a:solidFill>
                 </a:rPr>
-                <a:t>Overconfident, </a:t>
+                <a:t>Overconfident </a:t>
               </a:r>
             </a:p>
             <a:p>
@@ -9737,8 +9737,8 @@
           </p:nvSpPr>
           <p:spPr>
             <a:xfrm>
-              <a:off x="5114711" y="4706465"/>
-              <a:ext cx="2408601" cy="738664"/>
+              <a:off x="5118671" y="4532017"/>
+              <a:ext cx="2408601" cy="954107"/>
             </a:xfrm>
             <a:prstGeom prst="rect">
               <a:avLst/>
@@ -9752,21 +9752,21 @@
             <a:lstStyle/>
             <a:p>
               <a:r>
-                <a:rPr lang="en-US" sz="1400" dirty="0"/>
-                <a:t>Convert hypothesis into </a:t>
-              </a:r>
-            </a:p>
-            <a:p>
-              <a:r>
-                <a:rPr lang="en-US" sz="1400" dirty="0"/>
-                <a:t>a mathematical formula</a:t>
-              </a:r>
-            </a:p>
-            <a:p>
-              <a:r>
-                <a:rPr lang="en-US" sz="1400" dirty="0"/>
-                <a:t>Set model parameters</a:t>
-              </a:r>
+                <a:rPr lang="en-CA" sz="1400" dirty="0"/>
+                <a:t>Write the hypothesis as a formula. Set the numbers.</a:t>
+              </a:r>
+              <a:br>
+                <a:rPr lang="en-CA" sz="1400" dirty="0"/>
+              </a:br>
+              <a:r>
+                <a:rPr lang="en-CA" sz="1400" dirty="0"/>
+                <a:t>-&gt; </a:t>
+              </a:r>
+              <a:r>
+                <a:rPr lang="en-CA" sz="1400" i="1" dirty="0"/>
+                <a:t>Which processes generate y, and how large are they?</a:t>
+              </a:r>
+              <a:endParaRPr lang="en-US" sz="1400" i="1" dirty="0"/>
             </a:p>
           </p:txBody>
         </p:sp>
@@ -9784,8 +9784,8 @@
           </p:nvSpPr>
           <p:spPr>
             <a:xfrm>
-              <a:off x="5199132" y="4410640"/>
-              <a:ext cx="1830325" cy="307777"/>
+              <a:off x="5196382" y="4169901"/>
+              <a:ext cx="2199145" cy="307777"/>
             </a:xfrm>
             <a:prstGeom prst="rect">
               <a:avLst/>
@@ -9807,8 +9807,13 @@
             <a:p>
               <a:r>
                 <a:rPr lang="en-US" sz="1400" b="1" dirty="0"/>
-                <a:t>1. Mechanistic model</a:t>
-              </a:r>
+                <a:t>1. </a:t>
+              </a:r>
+              <a:r>
+                <a:rPr lang="en-CA" sz="1400" b="1" dirty="0"/>
+                <a:t>Build a generative model</a:t>
+              </a:r>
+              <a:endParaRPr lang="en-US" sz="1400" b="1" dirty="0"/>
             </a:p>
           </p:txBody>
         </p:sp>
@@ -9827,7 +9832,7 @@
           <p:spPr>
             <a:xfrm>
               <a:off x="4400499" y="3394486"/>
-              <a:ext cx="3314586" cy="738664"/>
+              <a:ext cx="3314586" cy="954107"/>
             </a:xfrm>
             <a:prstGeom prst="rect">
               <a:avLst/>
@@ -9842,20 +9847,19 @@
             <a:p>
               <a:r>
                 <a:rPr lang="en-US" sz="1400" dirty="0"/>
-                <a:t>Data simulation: </a:t>
+                <a:t>Generate and plot the data the model implies.</a:t>
               </a:r>
             </a:p>
             <a:p>
               <a:r>
                 <a:rPr lang="en-US" sz="1400" dirty="0"/>
-                <a:t>Set sample size and x values</a:t>
-              </a:r>
-            </a:p>
-            <a:p>
-              <a:r>
-                <a:rPr lang="en-US" sz="1400" dirty="0"/>
-                <a:t>Generate y-values from the model.</a:t>
-              </a:r>
+                <a:t>-&gt; </a:t>
+              </a:r>
+              <a:r>
+                <a:rPr lang="en-CA" sz="1400" dirty="0"/>
+                <a:t>Could my system really produce these data?</a:t>
+              </a:r>
+              <a:endParaRPr lang="en-US" sz="1400" dirty="0"/>
             </a:p>
           </p:txBody>
         </p:sp>
@@ -9874,7 +9878,7 @@
           <p:spPr>
             <a:xfrm>
               <a:off x="4834583" y="2103037"/>
-              <a:ext cx="2744726" cy="738664"/>
+              <a:ext cx="2744726" cy="954107"/>
             </a:xfrm>
             <a:prstGeom prst="rect">
               <a:avLst/>
@@ -9889,15 +9893,19 @@
             <a:p>
               <a:r>
                 <a:rPr lang="en-US" sz="1400" dirty="0"/>
-                <a:t>Explore potential and limitations:</a:t>
-              </a:r>
-              <a:br>
+                <a:t>Replay the study. Vary n, predictor range, effort.</a:t>
+              </a:r>
+            </a:p>
+            <a:p>
+              <a:r>
                 <a:rPr lang="en-US" sz="1400" dirty="0"/>
-              </a:br>
-              <a:r>
-                <a:rPr lang="en-US" sz="1400" dirty="0"/>
-                <a:t>manipulate and play with parameter settings</a:t>
-              </a:r>
+                <a:t>-&gt; </a:t>
+              </a:r>
+              <a:r>
+                <a:rPr lang="en-CA" sz="1400" dirty="0"/>
+                <a:t>Is the interval narrow enough for my claim?</a:t>
+              </a:r>
+              <a:endParaRPr lang="en-US" sz="1400" dirty="0"/>
             </a:p>
           </p:txBody>
         </p:sp>
@@ -9938,7 +9946,7 @@
             <a:p>
               <a:r>
                 <a:rPr lang="en-US" sz="1400" b="1" dirty="0"/>
-                <a:t>2. Simulation &amp; Visualization</a:t>
+                <a:t>2. Simulate and visualize</a:t>
               </a:r>
             </a:p>
           </p:txBody>
@@ -9980,306 +9988,11 @@
             <a:p>
               <a:r>
                 <a:rPr lang="en-US" sz="1400" b="1" dirty="0"/>
-                <a:t>3. Model check &amp; power analysis</a:t>
+                <a:t>3. Iterate the design</a:t>
               </a:r>
             </a:p>
           </p:txBody>
         </p:sp>
-        <p:sp>
-          <p:nvSpPr>
-            <p:cNvPr id="43" name="Rectangle 42">
-              <a:extLst>
-                <a:ext uri="{FF2B5EF4-FFF2-40B4-BE49-F238E27FC236}">
-                  <a16:creationId xmlns:a16="http://schemas.microsoft.com/office/drawing/2014/main" id="{8D2AC38E-5687-D54D-F328-1FA6A8C66BFC}"/>
-                </a:ext>
-              </a:extLst>
-            </p:cNvPr>
-            <p:cNvSpPr/>
-            <p:nvPr/>
-          </p:nvSpPr>
-          <p:spPr>
-            <a:xfrm>
-              <a:off x="9283335" y="-30409"/>
-              <a:ext cx="2996152" cy="3273365"/>
-            </a:xfrm>
-            <a:prstGeom prst="rect">
-              <a:avLst/>
-            </a:prstGeom>
-            <a:solidFill>
-              <a:schemeClr val="accent6">
-                <a:lumMod val="40000"/>
-                <a:lumOff val="60000"/>
-              </a:schemeClr>
-            </a:solidFill>
-          </p:spPr>
-          <p:style>
-            <a:lnRef idx="2">
-              <a:schemeClr val="accent1">
-                <a:shade val="15000"/>
-              </a:schemeClr>
-            </a:lnRef>
-            <a:fillRef idx="1">
-              <a:schemeClr val="accent1"/>
-            </a:fillRef>
-            <a:effectRef idx="0">
-              <a:schemeClr val="accent1"/>
-            </a:effectRef>
-            <a:fontRef idx="minor">
-              <a:schemeClr val="lt1"/>
-            </a:fontRef>
-          </p:style>
-          <p:txBody>
-            <a:bodyPr rtlCol="0" anchor="t"/>
-            <a:lstStyle/>
-            <a:p>
-              <a:r>
-                <a:rPr lang="en-US" sz="1400" b="1" dirty="0">
-                  <a:solidFill>
-                    <a:schemeClr val="tx1"/>
-                  </a:solidFill>
-                </a:rPr>
-                <a:t>Guiding questions</a:t>
-              </a:r>
-            </a:p>
-            <a:p>
-              <a:r>
-                <a:rPr lang="en-US" sz="1400" b="1" i="1" dirty="0">
-                  <a:solidFill>
-                    <a:schemeClr val="tx1"/>
-                  </a:solidFill>
-                </a:rPr>
-                <a:t>1. Step: Build mechanistic model</a:t>
-              </a:r>
-              <a:endParaRPr lang="en-US" sz="500" b="1" i="1" dirty="0">
-                <a:solidFill>
-                  <a:schemeClr val="tx1"/>
-                </a:solidFill>
-              </a:endParaRPr>
-            </a:p>
-            <a:p>
-              <a:pPr marL="285750" indent="-285750">
-                <a:buFont typeface="Arial" panose="020B0604020202020204" pitchFamily="34" charset="0"/>
-                <a:buChar char="•"/>
-              </a:pPr>
-              <a:r>
-                <a:rPr lang="en-US" sz="1400" dirty="0">
-                  <a:solidFill>
-                    <a:schemeClr val="tx1"/>
-                  </a:solidFill>
-                </a:rPr>
-                <a:t>What variable(s) influence y?</a:t>
-              </a:r>
-            </a:p>
-            <a:p>
-              <a:pPr marL="285750" indent="-285750">
-                <a:buFont typeface="Arial" panose="020B0604020202020204" pitchFamily="34" charset="0"/>
-                <a:buChar char="•"/>
-              </a:pPr>
-              <a:r>
-                <a:rPr lang="en-US" sz="1400" dirty="0">
-                  <a:solidFill>
-                    <a:schemeClr val="tx1"/>
-                  </a:solidFill>
-                </a:rPr>
-                <a:t>In what way? Linear/non-linear?</a:t>
-              </a:r>
-            </a:p>
-            <a:p>
-              <a:pPr marL="285750" indent="-285750">
-                <a:buFont typeface="Arial" panose="020B0604020202020204" pitchFamily="34" charset="0"/>
-                <a:buChar char="•"/>
-              </a:pPr>
-              <a:r>
-                <a:rPr lang="en-US" sz="1400" dirty="0">
-                  <a:solidFill>
-                    <a:schemeClr val="tx1"/>
-                  </a:solidFill>
-                </a:rPr>
-                <a:t>How much? e.g. effect sizes</a:t>
-              </a:r>
-            </a:p>
-            <a:p>
-              <a:pPr marL="285750" indent="-285750">
-                <a:buFont typeface="Arial" panose="020B0604020202020204" pitchFamily="34" charset="0"/>
-                <a:buChar char="•"/>
-              </a:pPr>
-              <a:r>
-                <a:rPr lang="en-US" sz="1400" dirty="0">
-                  <a:solidFill>
-                    <a:schemeClr val="tx1"/>
-                  </a:solidFill>
-                </a:rPr>
-                <a:t>How consistent? e.g. variance, background noise (error term)</a:t>
-              </a:r>
-            </a:p>
-            <a:p>
-              <a:r>
-                <a:rPr lang="en-US" sz="1400" b="1" i="1" dirty="0">
-                  <a:solidFill>
-                    <a:schemeClr val="tx1"/>
-                  </a:solidFill>
-                </a:rPr>
-                <a:t>2. Step: Generate fake data and plot</a:t>
-              </a:r>
-            </a:p>
-            <a:p>
-              <a:pPr marL="285750" indent="-285750">
-                <a:buFont typeface="Arial" panose="020B0604020202020204" pitchFamily="34" charset="0"/>
-                <a:buChar char="•"/>
-              </a:pPr>
-              <a:r>
-                <a:rPr lang="en-US" sz="1400" i="1" dirty="0">
-                  <a:solidFill>
-                    <a:schemeClr val="tx1"/>
-                  </a:solidFill>
-                </a:rPr>
-                <a:t>Does this match your predictions?</a:t>
-              </a:r>
-            </a:p>
-            <a:p>
-              <a:pPr marL="285750" indent="-285750">
-                <a:buFont typeface="Arial" panose="020B0604020202020204" pitchFamily="34" charset="0"/>
-                <a:buChar char="•"/>
-              </a:pPr>
-              <a:r>
-                <a:rPr lang="en-US" sz="1400" i="1" dirty="0">
-                  <a:solidFill>
-                    <a:schemeClr val="tx1"/>
-                  </a:solidFill>
-                </a:rPr>
-                <a:t>Is this a reasonable hypothesis?</a:t>
-              </a:r>
-            </a:p>
-            <a:p>
-              <a:r>
-                <a:rPr lang="en-US" sz="1400" b="1" i="1" dirty="0">
-                  <a:solidFill>
-                    <a:schemeClr val="tx1"/>
-                  </a:solidFill>
-                </a:rPr>
-                <a:t>3. Step: Explore and play</a:t>
-              </a:r>
-            </a:p>
-            <a:p>
-              <a:pPr marL="285750" indent="-285750">
-                <a:buFont typeface="Arial" panose="020B0604020202020204" pitchFamily="34" charset="0"/>
-                <a:buChar char="•"/>
-              </a:pPr>
-              <a:r>
-                <a:rPr lang="en-US" sz="1400" dirty="0">
-                  <a:solidFill>
-                    <a:schemeClr val="tx1"/>
-                  </a:solidFill>
-                </a:rPr>
-                <a:t>Enough statistical power? </a:t>
-              </a:r>
-            </a:p>
-            <a:p>
-              <a:pPr marL="285750" indent="-285750">
-                <a:buFont typeface="Arial" panose="020B0604020202020204" pitchFamily="34" charset="0"/>
-                <a:buChar char="•"/>
-              </a:pPr>
-              <a:r>
-                <a:rPr lang="en-US" sz="1400" dirty="0">
-                  <a:solidFill>
-                    <a:schemeClr val="tx1"/>
-                  </a:solidFill>
-                </a:rPr>
-                <a:t>Is the model appropriate, assumptions?</a:t>
-              </a:r>
-            </a:p>
-            <a:p>
-              <a:pPr marL="285750" indent="-285750">
-                <a:buFont typeface="Arial" panose="020B0604020202020204" pitchFamily="34" charset="0"/>
-                <a:buChar char="•"/>
-              </a:pPr>
-              <a:r>
-                <a:rPr lang="en-US" sz="1400" dirty="0">
-                  <a:solidFill>
-                    <a:schemeClr val="tx1"/>
-                  </a:solidFill>
-                </a:rPr>
-                <a:t>Alternative models?  </a:t>
-              </a:r>
-            </a:p>
-            <a:p>
-              <a:pPr marL="285750" indent="-285750">
-                <a:buFont typeface="Arial" panose="020B0604020202020204" pitchFamily="34" charset="0"/>
-                <a:buChar char="•"/>
-              </a:pPr>
-              <a:endParaRPr lang="en-US" sz="1400" dirty="0">
-                <a:solidFill>
-                  <a:schemeClr val="tx1"/>
-                </a:solidFill>
-              </a:endParaRPr>
-            </a:p>
-            <a:p>
-              <a:pPr marL="285750" indent="-285750">
-                <a:buFont typeface="Arial" panose="020B0604020202020204" pitchFamily="34" charset="0"/>
-                <a:buChar char="•"/>
-              </a:pPr>
-              <a:endParaRPr lang="en-US" sz="1400" dirty="0">
-                <a:solidFill>
-                  <a:schemeClr val="tx1"/>
-                </a:solidFill>
-              </a:endParaRPr>
-            </a:p>
-            <a:p>
-              <a:pPr marL="285750" indent="-285750">
-                <a:buFont typeface="Arial" panose="020B0604020202020204" pitchFamily="34" charset="0"/>
-                <a:buChar char="•"/>
-              </a:pPr>
-              <a:endParaRPr lang="en-US" sz="1400" dirty="0">
-                <a:solidFill>
-                  <a:schemeClr val="tx1"/>
-                </a:solidFill>
-              </a:endParaRPr>
-            </a:p>
-          </p:txBody>
-        </p:sp>
-        <p:cxnSp>
-          <p:nvCxnSpPr>
-            <p:cNvPr id="45" name="Straight Arrow Connector 44">
-              <a:extLst>
-                <a:ext uri="{FF2B5EF4-FFF2-40B4-BE49-F238E27FC236}">
-                  <a16:creationId xmlns:a16="http://schemas.microsoft.com/office/drawing/2014/main" id="{F73A32AE-C38A-CC0E-5E20-1A23E09E04DE}"/>
-                </a:ext>
-              </a:extLst>
-            </p:cNvPr>
-            <p:cNvCxnSpPr>
-              <a:cxnSpLocks/>
-              <a:stCxn id="43" idx="2"/>
-            </p:cNvCxnSpPr>
-            <p:nvPr/>
-          </p:nvCxnSpPr>
-          <p:spPr>
-            <a:xfrm flipH="1">
-              <a:off x="8438108" y="3242956"/>
-              <a:ext cx="2343303" cy="692219"/>
-            </a:xfrm>
-            <a:prstGeom prst="straightConnector1">
-              <a:avLst/>
-            </a:prstGeom>
-            <a:ln w="25400">
-              <a:headEnd w="lg" len="lg"/>
-              <a:tailEnd type="oval"/>
-            </a:ln>
-          </p:spPr>
-          <p:style>
-            <a:lnRef idx="1">
-              <a:schemeClr val="accent1"/>
-            </a:lnRef>
-            <a:fillRef idx="0">
-              <a:schemeClr val="accent1"/>
-            </a:fillRef>
-            <a:effectRef idx="0">
-              <a:schemeClr val="accent1"/>
-            </a:effectRef>
-            <a:fontRef idx="minor">
-              <a:schemeClr val="tx1"/>
-            </a:fontRef>
-          </p:style>
-        </p:cxnSp>
         <p:sp>
           <p:nvSpPr>
             <p:cNvPr id="52" name="TextBox 51">
@@ -10326,7 +10039,7 @@
                     <a:srgbClr val="FF0000"/>
                   </a:solidFill>
                 </a:rPr>
-                <a:t>Garden of the forking paths </a:t>
+                <a:t>Garden of forking paths </a:t>
               </a:r>
               <a:endParaRPr lang="en-US" sz="1400" dirty="0"/>
             </a:p>

</xml_diff>